<commit_message>
Add MongoDB work and weekly folders
</commit_message>
<xml_diff>
--- a/WEEK-2-COREJAVA/Core_Java (2).pptx
+++ b/WEEK-2-COREJAVA/Core_Java (2).pptx
@@ -439,7 +439,7 @@
             <a:fld id="{B61BEF0D-F0BB-DE4B-95CE-6DB70DBA9567}" type="datetimeFigureOut">
               <a:rPr lang="en-US" dirty="0"/>
               <a:pPr/>
-              <a:t>8/30/2026</a:t>
+              <a:t>9/11/26</a:t>
             </a:fld>
             <a:endParaRPr lang="en-US" dirty="0"/>
           </a:p>
@@ -701,7 +701,7 @@
             <a:fld id="{B61BEF0D-F0BB-DE4B-95CE-6DB70DBA9567}" type="datetimeFigureOut">
               <a:rPr lang="en-US" dirty="0"/>
               <a:pPr/>
-              <a:t>8/30/2026</a:t>
+              <a:t>9/11/26</a:t>
             </a:fld>
             <a:endParaRPr lang="en-US" dirty="0"/>
           </a:p>
@@ -936,7 +936,7 @@
             <a:fld id="{B61BEF0D-F0BB-DE4B-95CE-6DB70DBA9567}" type="datetimeFigureOut">
               <a:rPr lang="en-US" dirty="0"/>
               <a:pPr/>
-              <a:t>8/30/2026</a:t>
+              <a:t>9/11/26</a:t>
             </a:fld>
             <a:endParaRPr lang="en-US" dirty="0"/>
           </a:p>
@@ -1183,7 +1183,7 @@
             <a:fld id="{B61BEF0D-F0BB-DE4B-95CE-6DB70DBA9567}" type="datetimeFigureOut">
               <a:rPr lang="en-US" dirty="0"/>
               <a:pPr/>
-              <a:t>8/30/2026</a:t>
+              <a:t>9/11/26</a:t>
             </a:fld>
             <a:endParaRPr lang="en-US" dirty="0"/>
           </a:p>
@@ -1491,7 +1491,7 @@
             <a:fld id="{B61BEF0D-F0BB-DE4B-95CE-6DB70DBA9567}" type="datetimeFigureOut">
               <a:rPr lang="en-US" dirty="0"/>
               <a:pPr/>
-              <a:t>8/30/2026</a:t>
+              <a:t>9/11/26</a:t>
             </a:fld>
             <a:endParaRPr lang="en-US" dirty="0"/>
           </a:p>
@@ -1792,7 +1792,7 @@
             <a:fld id="{B61BEF0D-F0BB-DE4B-95CE-6DB70DBA9567}" type="datetimeFigureOut">
               <a:rPr lang="en-US" dirty="0"/>
               <a:pPr/>
-              <a:t>8/30/2026</a:t>
+              <a:t>9/11/26</a:t>
             </a:fld>
             <a:endParaRPr lang="en-US" dirty="0"/>
           </a:p>
@@ -2213,7 +2213,7 @@
             <a:fld id="{B61BEF0D-F0BB-DE4B-95CE-6DB70DBA9567}" type="datetimeFigureOut">
               <a:rPr lang="en-US" dirty="0"/>
               <a:pPr/>
-              <a:t>8/30/2026</a:t>
+              <a:t>9/11/26</a:t>
             </a:fld>
             <a:endParaRPr lang="en-US" dirty="0"/>
           </a:p>
@@ -2376,7 +2376,7 @@
             <a:fld id="{B61BEF0D-F0BB-DE4B-95CE-6DB70DBA9567}" type="datetimeFigureOut">
               <a:rPr lang="en-US" dirty="0"/>
               <a:pPr/>
-              <a:t>8/30/2026</a:t>
+              <a:t>9/11/26</a:t>
             </a:fld>
             <a:endParaRPr lang="en-US" dirty="0"/>
           </a:p>
@@ -2473,7 +2473,7 @@
             <a:fld id="{B61BEF0D-F0BB-DE4B-95CE-6DB70DBA9567}" type="datetimeFigureOut">
               <a:rPr lang="en-US" dirty="0"/>
               <a:pPr/>
-              <a:t>8/30/2026</a:t>
+              <a:t>9/11/26</a:t>
             </a:fld>
             <a:endParaRPr lang="en-US" dirty="0"/>
           </a:p>
@@ -2851,7 +2851,7 @@
             <a:fld id="{B61BEF0D-F0BB-DE4B-95CE-6DB70DBA9567}" type="datetimeFigureOut">
               <a:rPr lang="en-US" dirty="0"/>
               <a:pPr/>
-              <a:t>8/30/2026</a:t>
+              <a:t>9/11/26</a:t>
             </a:fld>
             <a:endParaRPr lang="en-US" dirty="0"/>
           </a:p>
@@ -3137,7 +3137,7 @@
             <a:fld id="{B61BEF0D-F0BB-DE4B-95CE-6DB70DBA9567}" type="datetimeFigureOut">
               <a:rPr lang="en-US" dirty="0"/>
               <a:pPr/>
-              <a:t>8/30/2026</a:t>
+              <a:t>9/11/26</a:t>
             </a:fld>
             <a:endParaRPr lang="en-US" dirty="0"/>
           </a:p>
@@ -3376,7 +3376,7 @@
             <a:fld id="{B61BEF0D-F0BB-DE4B-95CE-6DB70DBA9567}" type="datetimeFigureOut">
               <a:rPr lang="en-US" dirty="0"/>
               <a:pPr/>
-              <a:t>8/30/2026</a:t>
+              <a:t>9/11/26</a:t>
             </a:fld>
             <a:endParaRPr lang="en-US" dirty="0"/>
           </a:p>
@@ -20775,7 +20775,7 @@
         </p:blipFill>
         <p:spPr>
           <a:xfrm>
-            <a:off x="1486167" y="4232744"/>
+            <a:off x="1251992" y="4277349"/>
             <a:ext cx="4279569" cy="1687019"/>
           </a:xfrm>
           <a:prstGeom prst="rect">

</xml_diff>